<commit_message>
Quick Guides: Inhalte aus den RAG-Batches, echte Hyperlinks, alle vier Varianten neu erzeugt
Neue Hinweise und Schritte zu Kilometerstandsprognose, Massenanlage,
Fahrzeuggruppen, Kampagnen, Codes und Kennungen (Kapitel 3, 5, 10 bis 12,
14 bis 16, 19, 21 bis 23); Übersichten mit 10.9, 12.9 und 15.7.
Generator: __Text|url__ und E-Mail-Adressen werden als Hyperlinks
ausgegeben, Hinweiszeile entsprechend formuliert; englische Fassung
über build_en.py mit den deutschen Änderungen abgeglichen.

Co-Authored-By: Claude Fable 5.1 <noreply@anthropic.com>
Claude-Session: https://claude.ai/code/session_01EhK4mVLcbJ5LMGgA3j15g8
</commit_message>
<xml_diff>
--- a/docs/quickguides/en/cars/pptx/03_Quick_Guide_oneSCM_Grundlagen_Navigation_und_Customer_Journey_EN_Cars.pptx
+++ b/docs/quickguides/en/cars/pptx/03_Quick_Guide_oneSCM_Grundlagen_Navigation_und_Customer_Journey_EN_Cars.pptx
@@ -1503,7 +1503,7 @@
                 <a:ea typeface="MB Corpo S Text Office" pitchFamily="34" charset="-122"/>
                 <a:cs typeface="MB Corpo S Text Office" pitchFamily="34" charset="-120"/>
               </a:rPr>
-              <a:t>This document is interactive – references to handbook chapters and systems are provided as links.</a:t>
+              <a:t>References to handbook chapters and systems are highlighted; e-mail addresses are provided as links.</a:t>
             </a:r>
             <a:endParaRPr lang="en-US" sz="900" dirty="0"/>
           </a:p>
@@ -3268,11 +3268,11 @@
         <p:spPr>
           <a:xfrm>
             <a:off x="201168" y="4242816"/>
-            <a:ext cx="4663440" cy="1170432"/>
+            <a:ext cx="4663440" cy="1316736"/>
           </a:xfrm>
           <a:prstGeom prst="roundRect">
             <a:avLst>
-              <a:gd name="adj" fmla="val 7813"/>
+              <a:gd name="adj" fmla="val 6944"/>
             </a:avLst>
           </a:prstGeom>
           <a:solidFill>
@@ -3336,7 +3336,7 @@
         <p:spPr>
           <a:xfrm>
             <a:off x="310896" y="4590288"/>
-            <a:ext cx="4480560" cy="768096"/>
+            <a:ext cx="4480560" cy="914400"/>
           </a:xfrm>
           <a:prstGeom prst="rect">
             <a:avLst/>
@@ -3406,7 +3406,7 @@
                 <a:ea typeface="MB Corpo S Text Office" pitchFamily="34" charset="-122"/>
                 <a:cs typeface="MB Corpo S Text Office" pitchFamily="34" charset="-120"/>
               </a:rPr>
-              <a:t>Browser zoom below 100 % hides columns; use the slider.</a:t>
+              <a:t>Wizards end uniformly with the step "Overview &amp; Confirmation"; market names appear in the language of the market settings (3.3, 3.9).</a:t>
             </a:r>
             <a:endParaRPr lang="en-US" sz="900" dirty="0"/>
           </a:p>

</xml_diff>